<commit_message>
Fix marketecture integration-card formatting
The integration step cards have ~20 characters of usable width and
step 1 renders its two body lines at fixed positions, so long body
text wrapped and overstruck. Shortened all step copy to single-line
widths (Pipelines as code / YAML via API; 8 silver routes / carrier +
UoM / Talend geo; 2 data products / API-attached / daily 06:00 UTC).
Verified via high-res PNG render against the canonical reference:
no collisions, all cards clean.

Co-Authored-By: Claude Fable 5 <noreply@anthropic.com>
</commit_message>
<xml_diff>
--- a/MCG_Marketecture.pptx
+++ b/MCG_Marketecture.pptx
@@ -3143,7 +3143,7 @@
                 <a:ea typeface="Inter" pitchFamily="34" charset="-122"/>
                 <a:cs typeface="Inter" pitchFamily="34" charset="-120"/>
               </a:rPr>
-              <a:t>Two declarative pipeline projects land three feeds as code</a:t>
+              <a:t>Two declarative projects land three feeds as code</a:t>
             </a:r>
             <a:endParaRPr lang="en-US" sz="1000" dirty="0"/>
           </a:p>
@@ -3270,7 +3270,7 @@
                 <a:ea typeface="Inter" pitchFamily="34" charset="-122"/>
                 <a:cs typeface="Inter" pitchFamily="34" charset="-120"/>
               </a:rPr>
-              <a:t>Declarative YAML pipelines — batch + streaming</a:t>
+              <a:t>Pipelines as code</a:t>
             </a:r>
             <a:endParaRPr lang="en-US" sz="1000" dirty="0"/>
           </a:p>
@@ -3309,7 +3309,7 @@
                 <a:ea typeface="Inter" pitchFamily="34" charset="-122"/>
                 <a:cs typeface="Inter" pitchFamily="34" charset="-120"/>
               </a:rPr>
-              <a:t>— imported via API, git-versioned</a:t>
+              <a:t>— YAML, via API</a:t>
             </a:r>
             <a:endParaRPr lang="en-US" sz="1000" dirty="0"/>
           </a:p>
@@ -3436,7 +3436,7 @@
                 <a:ea typeface="Inter" pitchFamily="34" charset="-122"/>
                 <a:cs typeface="Inter" pitchFamily="34" charset="-120"/>
               </a:rPr>
-              <a:t>8 silver transformation routes</a:t>
+              <a:t>8 silver routes</a:t>
             </a:r>
             <a:endParaRPr lang="en-US" sz="950" dirty="0"/>
           </a:p>
@@ -3453,7 +3453,7 @@
                 <a:ea typeface="Inter" pitchFamily="34" charset="-122"/>
                 <a:cs typeface="Inter" pitchFamily="34" charset="-120"/>
               </a:rPr>
-              <a:t>Carrier + UoM canonicalization</a:t>
+              <a:t>Carrier + UoM fixes</a:t>
             </a:r>
             <a:endParaRPr lang="en-US" sz="950" dirty="0"/>
           </a:p>
@@ -3470,7 +3470,7 @@
                 <a:ea typeface="Inter" pitchFamily="34" charset="-122"/>
                 <a:cs typeface="Inter" pitchFamily="34" charset="-120"/>
               </a:rPr>
-              <a:t>Talend address validation + geo</a:t>
+              <a:t>Talend geo checks</a:t>
             </a:r>
             <a:endParaRPr lang="en-US" sz="950" dirty="0"/>
           </a:p>
@@ -3504,7 +3504,7 @@
                 <a:ea typeface="Inter" pitchFamily="34" charset="-122"/>
                 <a:cs typeface="Inter" pitchFamily="34" charset="-120"/>
               </a:rPr>
-              <a:t>Stewardship for the rest</a:t>
+              <a:t>Stewardship the rest</a:t>
             </a:r>
             <a:endParaRPr lang="en-US" sz="950" dirty="0"/>
           </a:p>
@@ -3631,7 +3631,7 @@
                 <a:ea typeface="Inter" pitchFamily="34" charset="-122"/>
                 <a:cs typeface="Inter" pitchFamily="34" charset="-120"/>
               </a:rPr>
-              <a:t>Two governed data products</a:t>
+              <a:t>2 data products</a:t>
             </a:r>
             <a:endParaRPr lang="en-US" sz="950" dirty="0"/>
           </a:p>
@@ -3648,7 +3648,7 @@
                 <a:ea typeface="Inter" pitchFamily="34" charset="-122"/>
                 <a:cs typeface="Inter" pitchFamily="34" charset="-120"/>
               </a:rPr>
-              <a:t>Datasets attached via API</a:t>
+              <a:t>API-attached</a:t>
             </a:r>
             <a:endParaRPr lang="en-US" sz="950" dirty="0"/>
           </a:p>
@@ -3665,7 +3665,7 @@
                 <a:ea typeface="Inter" pitchFamily="34" charset="-122"/>
                 <a:cs typeface="Inter" pitchFamily="34" charset="-120"/>
               </a:rPr>
-              <a:t>Daily 06:00 UTC + event runs</a:t>
+              <a:t>Daily 06:00 UTC</a:t>
             </a:r>
             <a:endParaRPr lang="en-US" sz="950" dirty="0"/>
           </a:p>
@@ -3699,7 +3699,7 @@
                 <a:ea typeface="Inter" pitchFamily="34" charset="-122"/>
                 <a:cs typeface="Inter" pitchFamily="34" charset="-120"/>
               </a:rPr>
-              <a:t>Same tables, any engine</a:t>
+              <a:t>Open to any engine</a:t>
             </a:r>
             <a:endParaRPr lang="en-US" sz="950" dirty="0"/>
           </a:p>

</xml_diff>

<commit_message>
Move Talend into the marketecture integration column
Talend was framed as a source (column 1 'Validated addresses' card);
it belongs in Data Integration. Step 2 now carries 'Talend + Nominatim
/ address validation' alongside the silver routes, and the sixth
source card is the Salesforce Product master (an actual origin feed).
Verified clean via high-res render: no collisions, all step cards fit
with bold accents intact.

Co-Authored-By: Claude Fable 5 <noreply@anthropic.com>
</commit_message>
<xml_diff>
--- a/MCG_Marketecture.pptx
+++ b/MCG_Marketecture.pptx
@@ -2138,8 +2138,8 @@
         </p:blipFill>
         <p:spPr>
           <a:xfrm>
-            <a:off x="455676" y="4645152"/>
-            <a:ext cx="597408" cy="640080"/>
+            <a:off x="365760" y="4673727"/>
+            <a:ext cx="777240" cy="582930"/>
           </a:xfrm>
           <a:prstGeom prst="rect">
             <a:avLst/>
@@ -2179,7 +2179,7 @@
                 <a:ea typeface="Inter" pitchFamily="34" charset="-122"/>
                 <a:cs typeface="Inter" pitchFamily="34" charset="-120"/>
               </a:rPr>
-              <a:t>Operational docs</a:t>
+              <a:t>Product master</a:t>
             </a:r>
             <a:endParaRPr lang="en-US" sz="1200" dirty="0"/>
           </a:p>
@@ -2218,7 +2218,7 @@
                 <a:ea typeface="Inter" pitchFamily="34" charset="-122"/>
                 <a:cs typeface="Inter" pitchFamily="34" charset="-120"/>
               </a:rPr>
-              <a:t>SOPs + contracts</a:t>
+              <a:t>Salesforce objects</a:t>
             </a:r>
             <a:endParaRPr lang="en-US" sz="900" dirty="0"/>
           </a:p>
@@ -2257,7 +2257,7 @@
                 <a:ea typeface="Inter" pitchFamily="34" charset="-122"/>
                 <a:cs typeface="Inter" pitchFamily="34" charset="-120"/>
               </a:rPr>
-              <a:t>25 DOCX knowledge base</a:t>
+              <a:t>Weights · suppliers</a:t>
             </a:r>
             <a:endParaRPr lang="en-US" sz="900" dirty="0"/>
           </a:p>
@@ -2296,7 +2296,7 @@
                 <a:ea typeface="Inter" pitchFamily="34" charset="-122"/>
                 <a:cs typeface="Inter" pitchFamily="34" charset="-120"/>
               </a:rPr>
-              <a:t>Qlik Answers</a:t>
+              <a:t>Every 15 min</a:t>
             </a:r>
             <a:endParaRPr lang="en-US" sz="850" dirty="0"/>
           </a:p>
@@ -2368,8 +2368,8 @@
         </p:blipFill>
         <p:spPr>
           <a:xfrm>
-            <a:off x="434340" y="5486400"/>
-            <a:ext cx="640080" cy="640080"/>
+            <a:off x="455676" y="5486400"/>
+            <a:ext cx="597408" cy="640080"/>
           </a:xfrm>
           <a:prstGeom prst="rect">
             <a:avLst/>
@@ -2409,7 +2409,7 @@
                 <a:ea typeface="Inter" pitchFamily="34" charset="-122"/>
                 <a:cs typeface="Inter" pitchFamily="34" charset="-120"/>
               </a:rPr>
-              <a:t>Validated addresses</a:t>
+              <a:t>Operational docs</a:t>
             </a:r>
             <a:endParaRPr lang="en-US" sz="1200" dirty="0"/>
           </a:p>
@@ -2448,7 +2448,7 @@
                 <a:ea typeface="Inter" pitchFamily="34" charset="-122"/>
                 <a:cs typeface="Inter" pitchFamily="34" charset="-120"/>
               </a:rPr>
-              <a:t>Talend + Nominatim</a:t>
+              <a:t>SOPs + contracts</a:t>
             </a:r>
             <a:endParaRPr lang="en-US" sz="900" dirty="0"/>
           </a:p>
@@ -2487,7 +2487,7 @@
                 <a:ea typeface="Inter" pitchFamily="34" charset="-122"/>
                 <a:cs typeface="Inter" pitchFamily="34" charset="-120"/>
               </a:rPr>
-              <a:t>Geocoded QVD, 15 min</a:t>
+              <a:t>25 DOCX knowledge base</a:t>
             </a:r>
             <a:endParaRPr lang="en-US" sz="900" dirty="0"/>
           </a:p>
@@ -2526,7 +2526,7 @@
                 <a:ea typeface="Inter" pitchFamily="34" charset="-122"/>
                 <a:cs typeface="Inter" pitchFamily="34" charset="-120"/>
               </a:rPr>
-              <a:t>Stewardship loop</a:t>
+              <a:t>Qlik Answers</a:t>
             </a:r>
             <a:endParaRPr lang="en-US" sz="850" dirty="0"/>
           </a:p>
@@ -3470,7 +3470,24 @@
                 <a:ea typeface="Inter" pitchFamily="34" charset="-122"/>
                 <a:cs typeface="Inter" pitchFamily="34" charset="-120"/>
               </a:rPr>
-              <a:t>Talend geo checks</a:t>
+              <a:t>Talend + Nominatim</a:t>
+            </a:r>
+            <a:endParaRPr lang="en-US" sz="950" dirty="0"/>
+          </a:p>
+          <a:p>
+            <a:pPr indent="0" marL="0">
+              <a:buNone/>
+            </a:pPr>
+            <a:r>
+              <a:rPr lang="en-US" sz="950" dirty="0">
+                <a:solidFill>
+                  <a:srgbClr val="545659"/>
+                </a:solidFill>
+                <a:latin typeface="Inter" pitchFamily="34" charset="0"/>
+                <a:ea typeface="Inter" pitchFamily="34" charset="-122"/>
+                <a:cs typeface="Inter" pitchFamily="34" charset="-120"/>
+              </a:rPr>
+              <a:t>address validation</a:t>
             </a:r>
             <a:endParaRPr lang="en-US" sz="950" dirty="0"/>
           </a:p>

</xml_diff>